<commit_message>
Add team and presenter names to slides
Co-Authored-By: Claude Opus 5.5 <noreply@anthropic.com>
Claude-Session: https://claude.ai/code/session_016ezBbvT43XFUSs688HTzUP
</commit_message>
<xml_diff>
--- a/Tayseer_Digital_Adoption_Capstone.pptx
+++ b/Tayseer_Digital_Adoption_Capstone.pptx
@@ -3641,7 +3641,43 @@
       </p:sp>
       <p:sp>
         <p:nvSpPr>
-          <p:cNvPr id="3" name="Text 0"/>
+          <p:cNvPr id="3" name="Presenter"/>
+          <p:cNvSpPr txBox="1"/>
+          <p:nvPr/>
+        </p:nvSpPr>
+        <p:spPr>
+          <a:xfrm>
+            <a:off x="6949440" y="502920"/>
+            <a:ext cx="4572000" cy="320040"/>
+          </a:xfrm>
+          <a:prstGeom prst="rect">
+            <a:avLst/>
+          </a:prstGeom>
+          <a:noFill/>
+          <a:ln/>
+        </p:spPr>
+        <p:txBody>
+          <a:bodyPr wrap="square" lIns="0" tIns="0" rIns="0" bIns="0" rtlCol="0" anchor="ctr"/>
+          <a:lstStyle/>
+          <a:p>
+            <a:pPr algn="r" indent="0" marL="0">
+              <a:buNone/>
+            </a:pPr>
+            <a:r>
+              <a:rPr lang="en-US" sz="1200" dirty="0">
+                <a:solidFill>
+                  <a:schemeClr val="accent5"/>
+                </a:solidFill>
+              </a:rPr>
+              <a:t>Presenter: Ahmed Ali Alqahtani</a:t>
+            </a:r>
+            <a:endParaRPr lang="en-US" sz="1200" dirty="0"/>
+          </a:p>
+        </p:txBody>
+      </p:sp>
+      <p:sp>
+        <p:nvSpPr>
+          <p:cNvPr id="4" name="Text 0"/>
           <p:cNvSpPr/>
           <p:nvPr>
             <p:ph idx="101" type="title" hasCustomPrompt="1"/>
@@ -3682,7 +3718,7 @@
       </p:sp>
       <p:sp>
         <p:nvSpPr>
-          <p:cNvPr id="4" name="Ask box"/>
+          <p:cNvPr id="5" name="Ask box"/>
           <p:cNvSpPr/>
           <p:nvPr/>
         </p:nvSpPr>
@@ -3709,7 +3745,7 @@
       </p:sp>
       <p:sp>
         <p:nvSpPr>
-          <p:cNvPr id="5" name="Ask text"/>
+          <p:cNvPr id="6" name="Ask text"/>
           <p:cNvSpPr txBox="1"/>
           <p:nvPr/>
         </p:nvSpPr>
@@ -3756,7 +3792,7 @@
       </p:sp>
       <p:sp>
         <p:nvSpPr>
-          <p:cNvPr id="6" name="Stat 1"/>
+          <p:cNvPr id="7" name="Stat 1"/>
           <p:cNvSpPr txBox="1"/>
           <p:nvPr/>
         </p:nvSpPr>
@@ -3795,7 +3831,7 @@
       </p:sp>
       <p:sp>
         <p:nvSpPr>
-          <p:cNvPr id="7" name="Stat label 1"/>
+          <p:cNvPr id="8" name="Stat label 1"/>
           <p:cNvSpPr txBox="1"/>
           <p:nvPr/>
         </p:nvSpPr>
@@ -3831,7 +3867,7 @@
       </p:sp>
       <p:sp>
         <p:nvSpPr>
-          <p:cNvPr id="8" name="Stat 2"/>
+          <p:cNvPr id="9" name="Stat 2"/>
           <p:cNvSpPr txBox="1"/>
           <p:nvPr/>
         </p:nvSpPr>
@@ -3870,7 +3906,7 @@
       </p:sp>
       <p:sp>
         <p:nvSpPr>
-          <p:cNvPr id="9" name="Stat label 2"/>
+          <p:cNvPr id="10" name="Stat label 2"/>
           <p:cNvSpPr txBox="1"/>
           <p:nvPr/>
         </p:nvSpPr>
@@ -3906,7 +3942,7 @@
       </p:sp>
       <p:sp>
         <p:nvSpPr>
-          <p:cNvPr id="10" name="Stat 3"/>
+          <p:cNvPr id="11" name="Stat 3"/>
           <p:cNvSpPr txBox="1"/>
           <p:nvPr/>
         </p:nvSpPr>
@@ -3945,7 +3981,7 @@
       </p:sp>
       <p:sp>
         <p:nvSpPr>
-          <p:cNvPr id="11" name="Stat label 3"/>
+          <p:cNvPr id="12" name="Stat label 3"/>
           <p:cNvSpPr txBox="1"/>
           <p:nvPr/>
         </p:nvSpPr>
@@ -3981,13 +4017,13 @@
       </p:sp>
       <p:sp>
         <p:nvSpPr>
-          <p:cNvPr id="12" name="Big idea"/>
+          <p:cNvPr id="13" name="Big idea"/>
           <p:cNvSpPr txBox="1"/>
           <p:nvPr/>
         </p:nvSpPr>
         <p:spPr>
           <a:xfrm>
-            <a:off x="640080" y="5623560"/>
+            <a:off x="640080" y="5577840"/>
             <a:ext cx="10424160" cy="457200"/>
           </a:xfrm>
           <a:prstGeom prst="rect">
@@ -4017,14 +4053,14 @@
       </p:sp>
       <p:sp>
         <p:nvSpPr>
-          <p:cNvPr id="13" name="Team"/>
+          <p:cNvPr id="14" name="Team"/>
           <p:cNvSpPr txBox="1"/>
           <p:nvPr/>
         </p:nvSpPr>
         <p:spPr>
           <a:xfrm>
-            <a:off x="640080" y="6309360"/>
-            <a:ext cx="9601200" cy="320040"/>
+            <a:off x="640080" y="6236208"/>
+            <a:ext cx="10058400" cy="365760"/>
           </a:xfrm>
           <a:prstGeom prst="rect">
             <a:avLst/>
@@ -4040,14 +4076,14 @@
               <a:buNone/>
             </a:pPr>
             <a:r>
-              <a:rPr lang="en-US" sz="1100" dirty="0">
-                <a:solidFill>
-                  <a:schemeClr val="accent4"/>
-                </a:solidFill>
-              </a:rPr>
-              <a:t>Ahmed Ali Alqahtani · Mohammed Al-Ateeq · Ziyad Al-humayd  |  SDAIA Academy · SDA-DSC-112</a:t>
-            </a:r>
-            <a:endParaRPr lang="en-US" sz="1100" dirty="0"/>
+              <a:rPr lang="en-US" sz="1400" b="1" dirty="0">
+                <a:solidFill>
+                  <a:schemeClr val="bg1"/>
+                </a:solidFill>
+              </a:rPr>
+              <a:t>Ahmed Ali Alqahtani  ·  Mohammed Al-Ateeq  ·  Ziyad Al-humayd   |   SDAIA Academy · SDA-DSC-112</a:t>
+            </a:r>
+            <a:endParaRPr lang="en-US" sz="1400" dirty="0"/>
           </a:p>
         </p:txBody>
       </p:sp>
@@ -4161,7 +4197,43 @@
       </p:sp>
       <p:sp>
         <p:nvSpPr>
-          <p:cNvPr id="3" name="Text 0"/>
+          <p:cNvPr id="3" name="Presenter"/>
+          <p:cNvSpPr txBox="1"/>
+          <p:nvPr/>
+        </p:nvSpPr>
+        <p:spPr>
+          <a:xfrm>
+            <a:off x="6949440" y="365760"/>
+            <a:ext cx="4572000" cy="320040"/>
+          </a:xfrm>
+          <a:prstGeom prst="rect">
+            <a:avLst/>
+          </a:prstGeom>
+          <a:noFill/>
+          <a:ln/>
+        </p:spPr>
+        <p:txBody>
+          <a:bodyPr wrap="square" lIns="0" tIns="0" rIns="0" bIns="0" rtlCol="0" anchor="ctr"/>
+          <a:lstStyle/>
+          <a:p>
+            <a:pPr algn="r" indent="0" marL="0">
+              <a:buNone/>
+            </a:pPr>
+            <a:r>
+              <a:rPr lang="en-US" sz="1200" dirty="0">
+                <a:solidFill>
+                  <a:srgbClr val="5E6878"/>
+                </a:solidFill>
+              </a:rPr>
+              <a:t>Presenter: Ahmed Ali Alqahtani</a:t>
+            </a:r>
+            <a:endParaRPr lang="en-US" sz="1200" dirty="0"/>
+          </a:p>
+        </p:txBody>
+      </p:sp>
+      <p:sp>
+        <p:nvSpPr>
+          <p:cNvPr id="4" name="Text 0"/>
           <p:cNvSpPr/>
           <p:nvPr>
             <p:ph idx="101" type="title" hasCustomPrompt="1"/>
@@ -4202,7 +4274,7 @@
       </p:sp>
       <p:sp>
         <p:nvSpPr>
-          <p:cNvPr id="4" name="KPI card"/>
+          <p:cNvPr id="5" name="KPI card"/>
           <p:cNvSpPr/>
           <p:nvPr/>
         </p:nvSpPr>
@@ -4229,7 +4301,7 @@
       </p:sp>
       <p:sp>
         <p:nvSpPr>
-          <p:cNvPr id="5" name="Text 3"/>
+          <p:cNvPr id="6" name="Text 4"/>
           <p:cNvSpPr txBox="1"/>
           <p:nvPr/>
         </p:nvSpPr>
@@ -4265,7 +4337,7 @@
       </p:sp>
       <p:sp>
         <p:nvSpPr>
-          <p:cNvPr id="6" name="KPI value"/>
+          <p:cNvPr id="7" name="KPI value"/>
           <p:cNvSpPr txBox="1"/>
           <p:nvPr/>
         </p:nvSpPr>
@@ -4304,7 +4376,7 @@
       </p:sp>
       <p:sp>
         <p:nvSpPr>
-          <p:cNvPr id="7" name="Text 5"/>
+          <p:cNvPr id="8" name="Text 6"/>
           <p:cNvSpPr txBox="1"/>
           <p:nvPr/>
         </p:nvSpPr>
@@ -4340,7 +4412,7 @@
       </p:sp>
       <p:sp>
         <p:nvSpPr>
-          <p:cNvPr id="8" name="Text 6"/>
+          <p:cNvPr id="9" name="Text 7"/>
           <p:cNvSpPr txBox="1"/>
           <p:nvPr/>
         </p:nvSpPr>
@@ -4376,7 +4448,7 @@
       </p:sp>
       <p:graphicFrame>
         <p:nvGraphicFramePr>
-          <p:cNvPr id="9" name="Leaders chart" descr=""/>
+          <p:cNvPr id="10" name="Leaders chart" descr=""/>
           <p:cNvGraphicFramePr/>
           <p:nvPr/>
         </p:nvGraphicFramePr>
@@ -4500,7 +4572,43 @@
       </p:sp>
       <p:sp>
         <p:nvSpPr>
-          <p:cNvPr id="3" name="Text 0"/>
+          <p:cNvPr id="3" name="Presenter"/>
+          <p:cNvSpPr txBox="1"/>
+          <p:nvPr/>
+        </p:nvSpPr>
+        <p:spPr>
+          <a:xfrm>
+            <a:off x="6949440" y="365760"/>
+            <a:ext cx="4572000" cy="320040"/>
+          </a:xfrm>
+          <a:prstGeom prst="rect">
+            <a:avLst/>
+          </a:prstGeom>
+          <a:noFill/>
+          <a:ln/>
+        </p:spPr>
+        <p:txBody>
+          <a:bodyPr wrap="square" lIns="0" tIns="0" rIns="0" bIns="0" rtlCol="0" anchor="ctr"/>
+          <a:lstStyle/>
+          <a:p>
+            <a:pPr algn="r" indent="0" marL="0">
+              <a:buNone/>
+            </a:pPr>
+            <a:r>
+              <a:rPr lang="en-US" sz="1200" dirty="0">
+                <a:solidFill>
+                  <a:srgbClr val="5E6878"/>
+                </a:solidFill>
+              </a:rPr>
+              <a:t>Presenter: Mohammed Al-Ateeq</a:t>
+            </a:r>
+            <a:endParaRPr lang="en-US" sz="1200" dirty="0"/>
+          </a:p>
+        </p:txBody>
+      </p:sp>
+      <p:sp>
+        <p:nvSpPr>
+          <p:cNvPr id="4" name="Text 0"/>
           <p:cNvSpPr/>
           <p:nvPr>
             <p:ph idx="101" type="title" hasCustomPrompt="1"/>
@@ -4541,7 +4649,7 @@
       </p:sp>
       <p:graphicFrame>
         <p:nvGraphicFramePr>
-          <p:cNvPr id="4" name="Regional chart" descr=""/>
+          <p:cNvPr id="5" name="Regional chart" descr=""/>
           <p:cNvGraphicFramePr/>
           <p:nvPr/>
         </p:nvGraphicFramePr>
@@ -4557,7 +4665,7 @@
       </p:graphicFrame>
       <p:sp>
         <p:nvSpPr>
-          <p:cNvPr id="5" name="Text 2"/>
+          <p:cNvPr id="6" name="Text 3"/>
           <p:cNvSpPr txBox="1"/>
           <p:nvPr/>
         </p:nvSpPr>
@@ -4593,7 +4701,7 @@
       </p:sp>
       <p:sp>
         <p:nvSpPr>
-          <p:cNvPr id="6" name="Takeaway card"/>
+          <p:cNvPr id="7" name="Takeaway card"/>
           <p:cNvSpPr/>
           <p:nvPr/>
         </p:nvSpPr>
@@ -4620,7 +4728,7 @@
       </p:sp>
       <p:sp>
         <p:nvSpPr>
-          <p:cNvPr id="7" name="Shape 4"/>
+          <p:cNvPr id="8" name="Shape 5"/>
           <p:cNvSpPr/>
           <p:nvPr/>
         </p:nvSpPr>
@@ -4645,7 +4753,7 @@
       </p:sp>
       <p:sp>
         <p:nvSpPr>
-          <p:cNvPr id="8" name="Text 5"/>
+          <p:cNvPr id="9" name="Text 6"/>
           <p:cNvSpPr txBox="1"/>
           <p:nvPr/>
         </p:nvSpPr>
@@ -4681,7 +4789,7 @@
       </p:sp>
       <p:sp>
         <p:nvSpPr>
-          <p:cNvPr id="9" name="Shape 6"/>
+          <p:cNvPr id="10" name="Shape 7"/>
           <p:cNvSpPr/>
           <p:nvPr/>
         </p:nvSpPr>
@@ -4706,7 +4814,7 @@
       </p:sp>
       <p:sp>
         <p:nvSpPr>
-          <p:cNvPr id="10" name="Text 7"/>
+          <p:cNvPr id="11" name="Text 8"/>
           <p:cNvSpPr txBox="1"/>
           <p:nvPr/>
         </p:nvSpPr>
@@ -4742,7 +4850,7 @@
       </p:sp>
       <p:sp>
         <p:nvSpPr>
-          <p:cNvPr id="11" name="Text 8"/>
+          <p:cNvPr id="12" name="Text 9"/>
           <p:cNvSpPr txBox="1"/>
           <p:nvPr/>
         </p:nvSpPr>
@@ -4781,7 +4889,7 @@
       </p:sp>
       <p:sp>
         <p:nvSpPr>
-          <p:cNvPr id="12" name="Text 9"/>
+          <p:cNvPr id="13" name="Text 10"/>
           <p:cNvSpPr txBox="1"/>
           <p:nvPr/>
         </p:nvSpPr>
@@ -4817,7 +4925,7 @@
       </p:sp>
       <p:sp>
         <p:nvSpPr>
-          <p:cNvPr id="13" name="Text 10"/>
+          <p:cNvPr id="14" name="Text 11"/>
           <p:cNvSpPr txBox="1"/>
           <p:nvPr/>
         </p:nvSpPr>
@@ -4961,7 +5069,43 @@
       </p:sp>
       <p:sp>
         <p:nvSpPr>
-          <p:cNvPr id="3" name="Text 0"/>
+          <p:cNvPr id="3" name="Presenter"/>
+          <p:cNvSpPr txBox="1"/>
+          <p:nvPr/>
+        </p:nvSpPr>
+        <p:spPr>
+          <a:xfrm>
+            <a:off x="6949440" y="365760"/>
+            <a:ext cx="4572000" cy="320040"/>
+          </a:xfrm>
+          <a:prstGeom prst="rect">
+            <a:avLst/>
+          </a:prstGeom>
+          <a:noFill/>
+          <a:ln/>
+        </p:spPr>
+        <p:txBody>
+          <a:bodyPr wrap="square" lIns="0" tIns="0" rIns="0" bIns="0" rtlCol="0" anchor="ctr"/>
+          <a:lstStyle/>
+          <a:p>
+            <a:pPr algn="r" indent="0" marL="0">
+              <a:buNone/>
+            </a:pPr>
+            <a:r>
+              <a:rPr lang="en-US" sz="1200" dirty="0">
+                <a:solidFill>
+                  <a:srgbClr val="5E6878"/>
+                </a:solidFill>
+              </a:rPr>
+              <a:t>Presenter: Mohammed Al-Ateeq</a:t>
+            </a:r>
+            <a:endParaRPr lang="en-US" sz="1200" dirty="0"/>
+          </a:p>
+        </p:txBody>
+      </p:sp>
+      <p:sp>
+        <p:nvSpPr>
+          <p:cNvPr id="4" name="Text 0"/>
           <p:cNvSpPr/>
           <p:nvPr>
             <p:ph idx="101" type="title" hasCustomPrompt="1"/>
@@ -5002,7 +5146,7 @@
       </p:sp>
       <p:graphicFrame>
         <p:nvGraphicFramePr>
-          <p:cNvPr id="4" name="Gap chart" descr=""/>
+          <p:cNvPr id="5" name="Gap chart" descr=""/>
           <p:cNvGraphicFramePr/>
           <p:nvPr/>
         </p:nvGraphicFramePr>
@@ -5018,7 +5162,7 @@
       </p:graphicFrame>
       <p:sp>
         <p:nvSpPr>
-          <p:cNvPr id="5" name="Tier 1 card"/>
+          <p:cNvPr id="6" name="Tier 1 card"/>
           <p:cNvSpPr/>
           <p:nvPr/>
         </p:nvSpPr>
@@ -5045,7 +5189,7 @@
       </p:sp>
       <p:sp>
         <p:nvSpPr>
-          <p:cNvPr id="6" name="Shape 3"/>
+          <p:cNvPr id="7" name="Shape 4"/>
           <p:cNvSpPr/>
           <p:nvPr/>
         </p:nvSpPr>
@@ -5070,7 +5214,7 @@
       </p:sp>
       <p:sp>
         <p:nvSpPr>
-          <p:cNvPr id="7" name="Text 4"/>
+          <p:cNvPr id="8" name="Text 5"/>
           <p:cNvSpPr txBox="1"/>
           <p:nvPr/>
         </p:nvSpPr>
@@ -5106,7 +5250,7 @@
       </p:sp>
       <p:sp>
         <p:nvSpPr>
-          <p:cNvPr id="8" name="Text 5"/>
+          <p:cNvPr id="9" name="Text 6"/>
           <p:cNvSpPr txBox="1"/>
           <p:nvPr/>
         </p:nvSpPr>
@@ -5142,7 +5286,7 @@
       </p:sp>
       <p:sp>
         <p:nvSpPr>
-          <p:cNvPr id="9" name="Text 6"/>
+          <p:cNvPr id="10" name="Text 7"/>
           <p:cNvSpPr txBox="1"/>
           <p:nvPr/>
         </p:nvSpPr>
@@ -5178,7 +5322,7 @@
       </p:sp>
       <p:sp>
         <p:nvSpPr>
-          <p:cNvPr id="10" name="Tier 2 card"/>
+          <p:cNvPr id="11" name="Tier 2 card"/>
           <p:cNvSpPr/>
           <p:nvPr/>
         </p:nvSpPr>
@@ -5205,7 +5349,7 @@
       </p:sp>
       <p:sp>
         <p:nvSpPr>
-          <p:cNvPr id="11" name="Shape 8"/>
+          <p:cNvPr id="12" name="Shape 9"/>
           <p:cNvSpPr/>
           <p:nvPr/>
         </p:nvSpPr>
@@ -5230,7 +5374,7 @@
       </p:sp>
       <p:sp>
         <p:nvSpPr>
-          <p:cNvPr id="12" name="Text 9"/>
+          <p:cNvPr id="13" name="Text 10"/>
           <p:cNvSpPr txBox="1"/>
           <p:nvPr/>
         </p:nvSpPr>
@@ -5266,7 +5410,7 @@
       </p:sp>
       <p:sp>
         <p:nvSpPr>
-          <p:cNvPr id="13" name="Text 10"/>
+          <p:cNvPr id="14" name="Text 11"/>
           <p:cNvSpPr txBox="1"/>
           <p:nvPr/>
         </p:nvSpPr>
@@ -5302,7 +5446,7 @@
       </p:sp>
       <p:sp>
         <p:nvSpPr>
-          <p:cNvPr id="14" name="Text 11"/>
+          <p:cNvPr id="15" name="Text 12"/>
           <p:cNvSpPr txBox="1"/>
           <p:nvPr/>
         </p:nvSpPr>
@@ -5446,7 +5590,43 @@
       </p:sp>
       <p:sp>
         <p:nvSpPr>
-          <p:cNvPr id="3" name="Text 0"/>
+          <p:cNvPr id="3" name="Presenter"/>
+          <p:cNvSpPr txBox="1"/>
+          <p:nvPr/>
+        </p:nvSpPr>
+        <p:spPr>
+          <a:xfrm>
+            <a:off x="6949440" y="365760"/>
+            <a:ext cx="4572000" cy="320040"/>
+          </a:xfrm>
+          <a:prstGeom prst="rect">
+            <a:avLst/>
+          </a:prstGeom>
+          <a:noFill/>
+          <a:ln/>
+        </p:spPr>
+        <p:txBody>
+          <a:bodyPr wrap="square" lIns="0" tIns="0" rIns="0" bIns="0" rtlCol="0" anchor="ctr"/>
+          <a:lstStyle/>
+          <a:p>
+            <a:pPr algn="r" indent="0" marL="0">
+              <a:buNone/>
+            </a:pPr>
+            <a:r>
+              <a:rPr lang="en-US" sz="1200" dirty="0">
+                <a:solidFill>
+                  <a:srgbClr val="5E6878"/>
+                </a:solidFill>
+              </a:rPr>
+              <a:t>Presenter: Ziyad Al-humayd</a:t>
+            </a:r>
+            <a:endParaRPr lang="en-US" sz="1200" dirty="0"/>
+          </a:p>
+        </p:txBody>
+      </p:sp>
+      <p:sp>
+        <p:nvSpPr>
+          <p:cNvPr id="4" name="Text 0"/>
           <p:cNvSpPr/>
           <p:nvPr>
             <p:ph idx="101" type="title" hasCustomPrompt="1"/>
@@ -5487,7 +5667,7 @@
       </p:sp>
       <p:sp>
         <p:nvSpPr>
-          <p:cNvPr id="4" name="Option A card"/>
+          <p:cNvPr id="5" name="Option A card"/>
           <p:cNvSpPr/>
           <p:nvPr/>
         </p:nvSpPr>
@@ -5514,7 +5694,7 @@
       </p:sp>
       <p:sp>
         <p:nvSpPr>
-          <p:cNvPr id="5" name="Shape 3"/>
+          <p:cNvPr id="6" name="Shape 4"/>
           <p:cNvSpPr/>
           <p:nvPr/>
         </p:nvSpPr>
@@ -5539,7 +5719,7 @@
       </p:sp>
       <p:sp>
         <p:nvSpPr>
-          <p:cNvPr id="6" name="Text 4"/>
+          <p:cNvPr id="7" name="Text 5"/>
           <p:cNvSpPr txBox="1"/>
           <p:nvPr/>
         </p:nvSpPr>
@@ -5575,7 +5755,7 @@
       </p:sp>
       <p:sp>
         <p:nvSpPr>
-          <p:cNvPr id="7" name="Text 5"/>
+          <p:cNvPr id="8" name="Text 6"/>
           <p:cNvSpPr txBox="1"/>
           <p:nvPr/>
         </p:nvSpPr>
@@ -5611,7 +5791,7 @@
       </p:sp>
       <p:sp>
         <p:nvSpPr>
-          <p:cNvPr id="8" name="Text 6"/>
+          <p:cNvPr id="9" name="Text 7"/>
           <p:cNvSpPr txBox="1"/>
           <p:nvPr/>
         </p:nvSpPr>
@@ -5647,7 +5827,7 @@
       </p:sp>
       <p:sp>
         <p:nvSpPr>
-          <p:cNvPr id="9" name="Text 7"/>
+          <p:cNvPr id="10" name="Text 8"/>
           <p:cNvSpPr txBox="1"/>
           <p:nvPr/>
         </p:nvSpPr>
@@ -5723,7 +5903,7 @@
       </p:sp>
       <p:sp>
         <p:nvSpPr>
-          <p:cNvPr id="10" name="Text 8"/>
+          <p:cNvPr id="11" name="Text 9"/>
           <p:cNvSpPr txBox="1"/>
           <p:nvPr/>
         </p:nvSpPr>
@@ -5759,7 +5939,7 @@
       </p:sp>
       <p:sp>
         <p:nvSpPr>
-          <p:cNvPr id="11" name="Option B card"/>
+          <p:cNvPr id="12" name="Option B card"/>
           <p:cNvSpPr/>
           <p:nvPr/>
         </p:nvSpPr>
@@ -5786,7 +5966,7 @@
       </p:sp>
       <p:sp>
         <p:nvSpPr>
-          <p:cNvPr id="12" name="Shape 10"/>
+          <p:cNvPr id="13" name="Shape 11"/>
           <p:cNvSpPr/>
           <p:nvPr/>
         </p:nvSpPr>
@@ -5811,7 +5991,7 @@
       </p:sp>
       <p:sp>
         <p:nvSpPr>
-          <p:cNvPr id="13" name="Text 11"/>
+          <p:cNvPr id="14" name="Text 12"/>
           <p:cNvSpPr txBox="1"/>
           <p:nvPr/>
         </p:nvSpPr>
@@ -5847,7 +6027,7 @@
       </p:sp>
       <p:sp>
         <p:nvSpPr>
-          <p:cNvPr id="14" name="Text 12"/>
+          <p:cNvPr id="15" name="Text 13"/>
           <p:cNvSpPr txBox="1"/>
           <p:nvPr/>
         </p:nvSpPr>
@@ -5883,7 +6063,7 @@
       </p:sp>
       <p:sp>
         <p:nvSpPr>
-          <p:cNvPr id="15" name="Text 13"/>
+          <p:cNvPr id="16" name="Text 14"/>
           <p:cNvSpPr txBox="1"/>
           <p:nvPr/>
         </p:nvSpPr>
@@ -5919,7 +6099,7 @@
       </p:sp>
       <p:sp>
         <p:nvSpPr>
-          <p:cNvPr id="16" name="Text 14"/>
+          <p:cNvPr id="17" name="Text 15"/>
           <p:cNvSpPr txBox="1"/>
           <p:nvPr/>
         </p:nvSpPr>
@@ -5995,7 +6175,7 @@
       </p:sp>
       <p:sp>
         <p:nvSpPr>
-          <p:cNvPr id="17" name="Text 15"/>
+          <p:cNvPr id="18" name="Text 16"/>
           <p:cNvSpPr txBox="1"/>
           <p:nvPr/>
         </p:nvSpPr>
@@ -6031,7 +6211,7 @@
       </p:sp>
       <p:sp>
         <p:nvSpPr>
-          <p:cNvPr id="18" name="Option C card"/>
+          <p:cNvPr id="19" name="Option C card"/>
           <p:cNvSpPr/>
           <p:nvPr/>
         </p:nvSpPr>
@@ -6058,7 +6238,7 @@
       </p:sp>
       <p:sp>
         <p:nvSpPr>
-          <p:cNvPr id="19" name="Shape 17"/>
+          <p:cNvPr id="20" name="Shape 18"/>
           <p:cNvSpPr/>
           <p:nvPr/>
         </p:nvSpPr>
@@ -6083,7 +6263,7 @@
       </p:sp>
       <p:sp>
         <p:nvSpPr>
-          <p:cNvPr id="20" name="Text 18"/>
+          <p:cNvPr id="21" name="Text 19"/>
           <p:cNvSpPr txBox="1"/>
           <p:nvPr/>
         </p:nvSpPr>
@@ -6119,7 +6299,7 @@
       </p:sp>
       <p:sp>
         <p:nvSpPr>
-          <p:cNvPr id="21" name="Text 19"/>
+          <p:cNvPr id="22" name="Text 20"/>
           <p:cNvSpPr txBox="1"/>
           <p:nvPr/>
         </p:nvSpPr>
@@ -6155,7 +6335,7 @@
       </p:sp>
       <p:sp>
         <p:nvSpPr>
-          <p:cNvPr id="22" name="Text 20"/>
+          <p:cNvPr id="23" name="Text 21"/>
           <p:cNvSpPr txBox="1"/>
           <p:nvPr/>
         </p:nvSpPr>
@@ -6191,7 +6371,7 @@
       </p:sp>
       <p:sp>
         <p:nvSpPr>
-          <p:cNvPr id="23" name="Text 21"/>
+          <p:cNvPr id="24" name="Text 22"/>
           <p:cNvSpPr txBox="1"/>
           <p:nvPr/>
         </p:nvSpPr>
@@ -6267,7 +6447,7 @@
       </p:sp>
       <p:sp>
         <p:nvSpPr>
-          <p:cNvPr id="24" name="Text 22"/>
+          <p:cNvPr id="25" name="Text 23"/>
           <p:cNvSpPr txBox="1"/>
           <p:nvPr/>
         </p:nvSpPr>
@@ -6411,7 +6591,43 @@
       </p:sp>
       <p:sp>
         <p:nvSpPr>
-          <p:cNvPr id="3" name="Text 0"/>
+          <p:cNvPr id="3" name="Presenter"/>
+          <p:cNvSpPr txBox="1"/>
+          <p:nvPr/>
+        </p:nvSpPr>
+        <p:spPr>
+          <a:xfrm>
+            <a:off x="6949440" y="365760"/>
+            <a:ext cx="4572000" cy="320040"/>
+          </a:xfrm>
+          <a:prstGeom prst="rect">
+            <a:avLst/>
+          </a:prstGeom>
+          <a:noFill/>
+          <a:ln/>
+        </p:spPr>
+        <p:txBody>
+          <a:bodyPr wrap="square" lIns="0" tIns="0" rIns="0" bIns="0" rtlCol="0" anchor="ctr"/>
+          <a:lstStyle/>
+          <a:p>
+            <a:pPr algn="r" indent="0" marL="0">
+              <a:buNone/>
+            </a:pPr>
+            <a:r>
+              <a:rPr lang="en-US" sz="1200" dirty="0">
+                <a:solidFill>
+                  <a:srgbClr val="5E6878"/>
+                </a:solidFill>
+              </a:rPr>
+              <a:t>Presenter: Ziyad Al-humayd</a:t>
+            </a:r>
+            <a:endParaRPr lang="en-US" sz="1200" dirty="0"/>
+          </a:p>
+        </p:txBody>
+      </p:sp>
+      <p:sp>
+        <p:nvSpPr>
+          <p:cNvPr id="4" name="Text 0"/>
           <p:cNvSpPr/>
           <p:nvPr>
             <p:ph idx="101" type="title" hasCustomPrompt="1"/>
@@ -6452,7 +6668,7 @@
       </p:sp>
       <p:graphicFrame>
         <p:nvGraphicFramePr>
-          <p:cNvPr id="4" name="Allocation chart" descr=""/>
+          <p:cNvPr id="5" name="Allocation chart" descr=""/>
           <p:cNvGraphicFramePr/>
           <p:nvPr/>
         </p:nvGraphicFramePr>
@@ -6468,7 +6684,7 @@
       </p:graphicFrame>
       <p:sp>
         <p:nvSpPr>
-          <p:cNvPr id="5" name="Why 1"/>
+          <p:cNvPr id="6" name="Why 1"/>
           <p:cNvSpPr/>
           <p:nvPr/>
         </p:nvSpPr>
@@ -6495,7 +6711,7 @@
       </p:sp>
       <p:sp>
         <p:nvSpPr>
-          <p:cNvPr id="6" name="Text 3"/>
+          <p:cNvPr id="7" name="Text 4"/>
           <p:cNvSpPr txBox="1"/>
           <p:nvPr/>
         </p:nvSpPr>
@@ -6531,7 +6747,7 @@
       </p:sp>
       <p:sp>
         <p:nvSpPr>
-          <p:cNvPr id="7" name="Text 4"/>
+          <p:cNvPr id="8" name="Text 5"/>
           <p:cNvSpPr txBox="1"/>
           <p:nvPr/>
         </p:nvSpPr>
@@ -6567,7 +6783,7 @@
       </p:sp>
       <p:sp>
         <p:nvSpPr>
-          <p:cNvPr id="8" name="Why 2"/>
+          <p:cNvPr id="9" name="Why 2"/>
           <p:cNvSpPr/>
           <p:nvPr/>
         </p:nvSpPr>
@@ -6594,7 +6810,7 @@
       </p:sp>
       <p:sp>
         <p:nvSpPr>
-          <p:cNvPr id="9" name="Text 6"/>
+          <p:cNvPr id="10" name="Text 7"/>
           <p:cNvSpPr txBox="1"/>
           <p:nvPr/>
         </p:nvSpPr>
@@ -6630,7 +6846,7 @@
       </p:sp>
       <p:sp>
         <p:nvSpPr>
-          <p:cNvPr id="10" name="Text 7"/>
+          <p:cNvPr id="11" name="Text 8"/>
           <p:cNvSpPr txBox="1"/>
           <p:nvPr/>
         </p:nvSpPr>
@@ -6666,7 +6882,7 @@
       </p:sp>
       <p:sp>
         <p:nvSpPr>
-          <p:cNvPr id="11" name="Why 3"/>
+          <p:cNvPr id="12" name="Why 3"/>
           <p:cNvSpPr/>
           <p:nvPr/>
         </p:nvSpPr>
@@ -6693,7 +6909,7 @@
       </p:sp>
       <p:sp>
         <p:nvSpPr>
-          <p:cNvPr id="12" name="Text 9"/>
+          <p:cNvPr id="13" name="Text 10"/>
           <p:cNvSpPr txBox="1"/>
           <p:nvPr/>
         </p:nvSpPr>
@@ -6729,7 +6945,7 @@
       </p:sp>
       <p:sp>
         <p:nvSpPr>
-          <p:cNvPr id="13" name="Text 10"/>
+          <p:cNvPr id="14" name="Text 11"/>
           <p:cNvSpPr txBox="1"/>
           <p:nvPr/>
         </p:nvSpPr>
@@ -6873,7 +7089,43 @@
       </p:sp>
       <p:sp>
         <p:nvSpPr>
-          <p:cNvPr id="3" name="Text 0"/>
+          <p:cNvPr id="3" name="Presenter"/>
+          <p:cNvSpPr txBox="1"/>
+          <p:nvPr/>
+        </p:nvSpPr>
+        <p:spPr>
+          <a:xfrm>
+            <a:off x="6949440" y="502920"/>
+            <a:ext cx="4572000" cy="320040"/>
+          </a:xfrm>
+          <a:prstGeom prst="rect">
+            <a:avLst/>
+          </a:prstGeom>
+          <a:noFill/>
+          <a:ln/>
+        </p:spPr>
+        <p:txBody>
+          <a:bodyPr wrap="square" lIns="0" tIns="0" rIns="0" bIns="0" rtlCol="0" anchor="ctr"/>
+          <a:lstStyle/>
+          <a:p>
+            <a:pPr algn="r" indent="0" marL="0">
+              <a:buNone/>
+            </a:pPr>
+            <a:r>
+              <a:rPr lang="en-US" sz="1200" dirty="0">
+                <a:solidFill>
+                  <a:schemeClr val="accent5"/>
+                </a:solidFill>
+              </a:rPr>
+              <a:t>Presenter: Ziyad Al-humayd</a:t>
+            </a:r>
+            <a:endParaRPr lang="en-US" sz="1200" dirty="0"/>
+          </a:p>
+        </p:txBody>
+      </p:sp>
+      <p:sp>
+        <p:nvSpPr>
+          <p:cNvPr id="4" name="Text 0"/>
           <p:cNvSpPr/>
           <p:nvPr>
             <p:ph idx="101" type="title" hasCustomPrompt="1"/>
@@ -6914,7 +7166,7 @@
       </p:sp>
       <p:sp>
         <p:nvSpPr>
-          <p:cNvPr id="4" name="Shape 2"/>
+          <p:cNvPr id="5" name="Shape 3"/>
           <p:cNvSpPr/>
           <p:nvPr/>
         </p:nvSpPr>
@@ -6939,7 +7191,7 @@
       </p:sp>
       <p:sp>
         <p:nvSpPr>
-          <p:cNvPr id="5" name="Text 3"/>
+          <p:cNvPr id="6" name="Text 4"/>
           <p:cNvSpPr txBox="1"/>
           <p:nvPr/>
         </p:nvSpPr>
@@ -6975,7 +7227,7 @@
       </p:sp>
       <p:sp>
         <p:nvSpPr>
-          <p:cNvPr id="6" name="Shape 4"/>
+          <p:cNvPr id="7" name="Shape 5"/>
           <p:cNvSpPr/>
           <p:nvPr/>
         </p:nvSpPr>
@@ -6998,7 +7250,7 @@
       </p:sp>
       <p:sp>
         <p:nvSpPr>
-          <p:cNvPr id="7" name="Text 5"/>
+          <p:cNvPr id="8" name="Text 6"/>
           <p:cNvSpPr txBox="1"/>
           <p:nvPr/>
         </p:nvSpPr>
@@ -7034,7 +7286,7 @@
       </p:sp>
       <p:sp>
         <p:nvSpPr>
-          <p:cNvPr id="8" name="Text 6"/>
+          <p:cNvPr id="9" name="Text 7"/>
           <p:cNvSpPr txBox="1"/>
           <p:nvPr/>
         </p:nvSpPr>
@@ -7073,7 +7325,7 @@
       </p:sp>
       <p:sp>
         <p:nvSpPr>
-          <p:cNvPr id="9" name="Text 7"/>
+          <p:cNvPr id="10" name="Text 8"/>
           <p:cNvSpPr txBox="1"/>
           <p:nvPr/>
         </p:nvSpPr>
@@ -7109,7 +7361,7 @@
       </p:sp>
       <p:sp>
         <p:nvSpPr>
-          <p:cNvPr id="10" name="Shape 8"/>
+          <p:cNvPr id="11" name="Shape 9"/>
           <p:cNvSpPr/>
           <p:nvPr/>
         </p:nvSpPr>
@@ -7134,7 +7386,7 @@
       </p:sp>
       <p:sp>
         <p:nvSpPr>
-          <p:cNvPr id="11" name="Text 9"/>
+          <p:cNvPr id="12" name="Text 10"/>
           <p:cNvSpPr txBox="1"/>
           <p:nvPr/>
         </p:nvSpPr>
@@ -7170,7 +7422,7 @@
       </p:sp>
       <p:sp>
         <p:nvSpPr>
-          <p:cNvPr id="12" name="Shape 10"/>
+          <p:cNvPr id="13" name="Shape 11"/>
           <p:cNvSpPr/>
           <p:nvPr/>
         </p:nvSpPr>
@@ -7193,7 +7445,7 @@
       </p:sp>
       <p:sp>
         <p:nvSpPr>
-          <p:cNvPr id="13" name="Text 11"/>
+          <p:cNvPr id="14" name="Text 12"/>
           <p:cNvSpPr txBox="1"/>
           <p:nvPr/>
         </p:nvSpPr>
@@ -7229,7 +7481,7 @@
       </p:sp>
       <p:sp>
         <p:nvSpPr>
-          <p:cNvPr id="14" name="Text 12"/>
+          <p:cNvPr id="15" name="Text 13"/>
           <p:cNvSpPr txBox="1"/>
           <p:nvPr/>
         </p:nvSpPr>
@@ -7268,7 +7520,7 @@
       </p:sp>
       <p:sp>
         <p:nvSpPr>
-          <p:cNvPr id="15" name="Text 13"/>
+          <p:cNvPr id="16" name="Text 14"/>
           <p:cNvSpPr txBox="1"/>
           <p:nvPr/>
         </p:nvSpPr>
@@ -7304,7 +7556,7 @@
       </p:sp>
       <p:sp>
         <p:nvSpPr>
-          <p:cNvPr id="16" name="Shape 14"/>
+          <p:cNvPr id="17" name="Shape 15"/>
           <p:cNvSpPr/>
           <p:nvPr/>
         </p:nvSpPr>
@@ -7329,7 +7581,7 @@
       </p:sp>
       <p:sp>
         <p:nvSpPr>
-          <p:cNvPr id="17" name="Text 15"/>
+          <p:cNvPr id="18" name="Text 16"/>
           <p:cNvSpPr txBox="1"/>
           <p:nvPr/>
         </p:nvSpPr>
@@ -7365,7 +7617,7 @@
       </p:sp>
       <p:sp>
         <p:nvSpPr>
-          <p:cNvPr id="18" name="Shape 16"/>
+          <p:cNvPr id="19" name="Shape 17"/>
           <p:cNvSpPr/>
           <p:nvPr/>
         </p:nvSpPr>
@@ -7388,7 +7640,7 @@
       </p:sp>
       <p:sp>
         <p:nvSpPr>
-          <p:cNvPr id="19" name="Text 17"/>
+          <p:cNvPr id="20" name="Text 18"/>
           <p:cNvSpPr txBox="1"/>
           <p:nvPr/>
         </p:nvSpPr>
@@ -7424,7 +7676,7 @@
       </p:sp>
       <p:sp>
         <p:nvSpPr>
-          <p:cNvPr id="20" name="Text 18"/>
+          <p:cNvPr id="21" name="Text 19"/>
           <p:cNvSpPr txBox="1"/>
           <p:nvPr/>
         </p:nvSpPr>
@@ -7463,7 +7715,7 @@
       </p:sp>
       <p:sp>
         <p:nvSpPr>
-          <p:cNvPr id="21" name="Text 19"/>
+          <p:cNvPr id="22" name="Text 20"/>
           <p:cNvSpPr txBox="1"/>
           <p:nvPr/>
         </p:nvSpPr>
@@ -7499,7 +7751,7 @@
       </p:sp>
       <p:sp>
         <p:nvSpPr>
-          <p:cNvPr id="22" name="Shape 20"/>
+          <p:cNvPr id="23" name="Shape 21"/>
           <p:cNvSpPr/>
           <p:nvPr/>
         </p:nvSpPr>
@@ -7524,7 +7776,7 @@
       </p:sp>
       <p:sp>
         <p:nvSpPr>
-          <p:cNvPr id="23" name="Text 21"/>
+          <p:cNvPr id="24" name="Text 22"/>
           <p:cNvSpPr txBox="1"/>
           <p:nvPr/>
         </p:nvSpPr>
@@ -7560,7 +7812,7 @@
       </p:sp>
       <p:sp>
         <p:nvSpPr>
-          <p:cNvPr id="24" name="Text 22"/>
+          <p:cNvPr id="25" name="Text 23"/>
           <p:cNvSpPr txBox="1"/>
           <p:nvPr/>
         </p:nvSpPr>
@@ -7596,7 +7848,7 @@
       </p:sp>
       <p:sp>
         <p:nvSpPr>
-          <p:cNvPr id="25" name="Text 23"/>
+          <p:cNvPr id="26" name="Text 24"/>
           <p:cNvSpPr txBox="1"/>
           <p:nvPr/>
         </p:nvSpPr>
@@ -7635,7 +7887,7 @@
       </p:sp>
       <p:sp>
         <p:nvSpPr>
-          <p:cNvPr id="26" name="Text 24"/>
+          <p:cNvPr id="27" name="Text 25"/>
           <p:cNvSpPr txBox="1"/>
           <p:nvPr/>
         </p:nvSpPr>
@@ -7671,7 +7923,7 @@
       </p:sp>
       <p:sp>
         <p:nvSpPr>
-          <p:cNvPr id="27" name="Closing ask"/>
+          <p:cNvPr id="28" name="Closing ask"/>
           <p:cNvSpPr txBox="1"/>
           <p:nvPr/>
         </p:nvSpPr>

</xml_diff>